<commit_message>
Clean up stale files, embed figures in PPTX, fix remaining citations
Cleanup:
- Delete 5 old v1 TIF figures (pre-overhaul)
- Delete 6 old v1 PNG/PDF figures (ConversionSim, Validation, MOSAIC)
- Delete 8 old pre-fix v3 figures (Architecture, MultiNuclease, etc.)
- Delete v2 manuscript and v2 cover letter (superseded by v3)
- Consolidate figures: v3_results/ renamed to v3/ (single directory)

PPTX with embedded figures (1.1 MB):
- Slide 11: Fig_StrategyDistribution_v2_v3 (BE rescue chart)
- Slide 13: Fig_BystanterFix (triple-count impact)
- Slide 16: Fig_CrossMethod_Agreement (TOPSIS/VIKOR/WPM)
- Slide 17: Fig_ConversionSim_CIs (tract distribution with CIs)
- Slide 20: Fig_ParameterProvenance (pie chart)
- Slide 21: Fig_LiteratureBenchmark (concordance)

Citation fixes:
- base_editing.py: Chakraborty -> Acharya et al., Nat Commun 15:5471
- test_multi_nuclease.py: same fix
- VALIDATION_REPORT.md: Kan citation (Genome Res, correct author Takasugi)

198 tests pass, 0 failures.
</commit_message>
<xml_diff>
--- a/paper/CRISPRArchitect_v3_LabMeeting.pptx
+++ b/paper/CRISPRArchitect_v3_LabMeeting.pptx
@@ -4555,16 +4555,40 @@
           </a:p>
         </p:txBody>
       </p:sp>
-      <p:sp>
-        <p:nvSpPr>
-          <p:cNvPr id="8" name="Rounded Rectangle 7"/>
+      <p:pic>
+        <p:nvPicPr>
+          <p:cNvPr id="8" name="Picture 7" descr="Fig_StrategyDistribution_v2_v3.png"/>
+          <p:cNvPicPr>
+            <a:picLocks noChangeAspect="1"/>
+          </p:cNvPicPr>
+          <p:nvPr/>
+        </p:nvPicPr>
+        <p:blipFill>
+          <a:blip r:embed="rId2"/>
+          <a:stretch>
+            <a:fillRect/>
+          </a:stretch>
+        </p:blipFill>
+        <p:spPr>
+          <a:xfrm>
+            <a:off x="640080" y="3017520"/>
+            <a:ext cx="5943600" cy="3200400"/>
+          </a:xfrm>
+          <a:prstGeom prst="rect">
+            <a:avLst/>
+          </a:prstGeom>
+        </p:spPr>
+      </p:pic>
+      <p:sp>
+        <p:nvSpPr>
+          <p:cNvPr id="9" name="Rounded Rectangle 8"/>
           <p:cNvSpPr/>
           <p:nvPr/>
         </p:nvSpPr>
         <p:spPr>
           <a:xfrm>
-            <a:off x="640080" y="3474720"/>
-            <a:ext cx="3200400" cy="1188720"/>
+            <a:off x="7132320" y="3200400"/>
+            <a:ext cx="2103120" cy="914400"/>
           </a:xfrm>
           <a:prstGeom prst="roundRect">
             <a:avLst/>
@@ -4600,14 +4624,14 @@
       </p:sp>
       <p:sp>
         <p:nvSpPr>
-          <p:cNvPr id="9" name="TextBox 8"/>
-          <p:cNvSpPr txBox="1"/>
-          <p:nvPr/>
-        </p:nvSpPr>
-        <p:spPr>
-          <a:xfrm>
-            <a:off x="640080" y="3611880"/>
-            <a:ext cx="3200400" cy="548640"/>
+          <p:cNvPr id="10" name="TextBox 9"/>
+          <p:cNvSpPr txBox="1"/>
+          <p:nvPr/>
+        </p:nvSpPr>
+        <p:spPr>
+          <a:xfrm>
+            <a:off x="7132320" y="3337560"/>
+            <a:ext cx="2103120" cy="548640"/>
           </a:xfrm>
           <a:prstGeom prst="rect">
             <a:avLst/>
@@ -4636,14 +4660,14 @@
       </p:sp>
       <p:sp>
         <p:nvSpPr>
-          <p:cNvPr id="10" name="TextBox 9"/>
-          <p:cNvSpPr txBox="1"/>
-          <p:nvPr/>
-        </p:nvSpPr>
-        <p:spPr>
-          <a:xfrm>
-            <a:off x="640080" y="4114800"/>
-            <a:ext cx="3200400" cy="365760"/>
+          <p:cNvPr id="11" name="TextBox 10"/>
+          <p:cNvSpPr txBox="1"/>
+          <p:nvPr/>
+        </p:nvSpPr>
+        <p:spPr>
+          <a:xfrm>
+            <a:off x="7132320" y="3840480"/>
+            <a:ext cx="2103120" cy="365760"/>
           </a:xfrm>
           <a:prstGeom prst="rect">
             <a:avLst/>
@@ -4665,21 +4689,21 @@
               </a:defRPr>
             </a:pPr>
             <a:r>
-              <a:t>BE Top-Ranked (v3)</a:t>
-            </a:r>
-          </a:p>
-        </p:txBody>
-      </p:sp>
-      <p:sp>
-        <p:nvSpPr>
-          <p:cNvPr id="11" name="Rounded Rectangle 10"/>
+              <a:t>BE v3</a:t>
+            </a:r>
+          </a:p>
+        </p:txBody>
+      </p:sp>
+      <p:sp>
+        <p:nvSpPr>
+          <p:cNvPr id="12" name="Rounded Rectangle 11"/>
           <p:cNvSpPr/>
           <p:nvPr/>
         </p:nvSpPr>
         <p:spPr>
           <a:xfrm>
-            <a:off x="4480560" y="3474720"/>
-            <a:ext cx="3200400" cy="1188720"/>
+            <a:off x="9418320" y="3200400"/>
+            <a:ext cx="2103120" cy="914400"/>
           </a:xfrm>
           <a:prstGeom prst="roundRect">
             <a:avLst/>
@@ -4715,14 +4739,14 @@
       </p:sp>
       <p:sp>
         <p:nvSpPr>
-          <p:cNvPr id="12" name="TextBox 11"/>
-          <p:cNvSpPr txBox="1"/>
-          <p:nvPr/>
-        </p:nvSpPr>
-        <p:spPr>
-          <a:xfrm>
-            <a:off x="4480560" y="3611880"/>
-            <a:ext cx="3200400" cy="548640"/>
+          <p:cNvPr id="13" name="TextBox 12"/>
+          <p:cNvSpPr txBox="1"/>
+          <p:nvPr/>
+        </p:nvSpPr>
+        <p:spPr>
+          <a:xfrm>
+            <a:off x="9418320" y="3337560"/>
+            <a:ext cx="2103120" cy="548640"/>
           </a:xfrm>
           <a:prstGeom prst="rect">
             <a:avLst/>
@@ -4751,14 +4775,14 @@
       </p:sp>
       <p:sp>
         <p:nvSpPr>
-          <p:cNvPr id="13" name="TextBox 12"/>
-          <p:cNvSpPr txBox="1"/>
-          <p:nvPr/>
-        </p:nvSpPr>
-        <p:spPr>
-          <a:xfrm>
-            <a:off x="4480560" y="4114800"/>
-            <a:ext cx="3200400" cy="365760"/>
+          <p:cNvPr id="14" name="TextBox 13"/>
+          <p:cNvSpPr txBox="1"/>
+          <p:nvPr/>
+        </p:nvSpPr>
+        <p:spPr>
+          <a:xfrm>
+            <a:off x="9418320" y="3840480"/>
+            <a:ext cx="2103120" cy="365760"/>
           </a:xfrm>
           <a:prstGeom prst="rect">
             <a:avLst/>
@@ -4780,51 +4804,8 @@
               </a:defRPr>
             </a:pPr>
             <a:r>
-              <a:t>BE Top-Ranked (v2)</a:t>
-            </a:r>
-          </a:p>
-        </p:txBody>
-      </p:sp>
-      <p:sp>
-        <p:nvSpPr>
-          <p:cNvPr id="14" name="Rounded Rectangle 13"/>
-          <p:cNvSpPr/>
-          <p:nvPr/>
-        </p:nvSpPr>
-        <p:spPr>
-          <a:xfrm>
-            <a:off x="8321040" y="3474720"/>
-            <a:ext cx="3200400" cy="1188720"/>
-          </a:xfrm>
-          <a:prstGeom prst="roundRect">
-            <a:avLst/>
-          </a:prstGeom>
-          <a:solidFill>
-            <a:srgbClr val="233448"/>
-          </a:solidFill>
-          <a:ln>
-            <a:noFill/>
-          </a:ln>
-        </p:spPr>
-        <p:style>
-          <a:lnRef idx="1">
-            <a:schemeClr val="accent1"/>
-          </a:lnRef>
-          <a:fillRef idx="3">
-            <a:schemeClr val="accent1"/>
-          </a:fillRef>
-          <a:effectRef idx="2">
-            <a:schemeClr val="accent1"/>
-          </a:effectRef>
-          <a:fontRef idx="minor">
-            <a:schemeClr val="lt1"/>
-          </a:fontRef>
-        </p:style>
-        <p:txBody>
-          <a:bodyPr rtlCol="0" anchor="ctr"/>
-          <a:lstStyle/>
-          <a:p>
-            <a:pPr algn="ctr"/>
+              <a:t>BE v2</a:t>
+            </a:r>
           </a:p>
         </p:txBody>
       </p:sp>
@@ -4836,30 +4817,42 @@
         </p:nvSpPr>
         <p:spPr>
           <a:xfrm>
-            <a:off x="8321040" y="3611880"/>
-            <a:ext cx="3200400" cy="548640"/>
-          </a:xfrm>
-          <a:prstGeom prst="rect">
-            <a:avLst/>
-          </a:prstGeom>
-          <a:noFill/>
-        </p:spPr>
-        <p:txBody>
-          <a:bodyPr wrap="square">
-            <a:spAutoFit/>
-          </a:bodyPr>
-          <a:lstStyle/>
-          <a:p>
-            <a:pPr algn="ctr">
-              <a:defRPr sz="3200" b="1">
-                <a:solidFill>
-                  <a:srgbClr val="1B9E77"/>
-                </a:solidFill>
-                <a:latin typeface="Calibri"/>
-              </a:defRPr>
-            </a:pPr>
-            <a:r>
-              <a:t>86.7%</a:t>
+            <a:off x="7132320" y="4572000"/>
+            <a:ext cx="4389120" cy="1371600"/>
+          </a:xfrm>
+          <a:prstGeom prst="rect">
+            <a:avLst/>
+          </a:prstGeom>
+          <a:noFill/>
+        </p:spPr>
+        <p:txBody>
+          <a:bodyPr wrap="square">
+            <a:spAutoFit/>
+          </a:bodyPr>
+          <a:lstStyle/>
+          <a:p>
+            <a:pPr algn="l">
+              <a:defRPr sz="1300" b="0">
+                <a:solidFill>
+                  <a:srgbClr val="CCCCCC"/>
+                </a:solidFill>
+                <a:latin typeface="Calibri"/>
+              </a:defRPr>
+            </a:pPr>
+            <a:r>
+              <a:t>Primary drivers:</a:t>
+            </a:r>
+            <a:br/>
+            <a:r>
+              <a:t>  ABE8e broader window (3-9)</a:t>
+            </a:r>
+            <a:br/>
+            <a:r>
+              <a:t>  enFnCas9 NRG PAM</a:t>
+            </a:r>
+            <a:br/>
+            <a:r>
+              <a:t>Bug fixed: bystander triple-count</a:t>
             </a:r>
           </a:p>
         </p:txBody>
@@ -4867,149 +4860,6 @@
       <p:sp>
         <p:nvSpPr>
           <p:cNvPr id="16" name="TextBox 15"/>
-          <p:cNvSpPr txBox="1"/>
-          <p:nvPr/>
-        </p:nvSpPr>
-        <p:spPr>
-          <a:xfrm>
-            <a:off x="8321040" y="4114800"/>
-            <a:ext cx="3200400" cy="365760"/>
-          </a:xfrm>
-          <a:prstGeom prst="rect">
-            <a:avLst/>
-          </a:prstGeom>
-          <a:noFill/>
-        </p:spPr>
-        <p:txBody>
-          <a:bodyPr wrap="square">
-            <a:spAutoFit/>
-          </a:bodyPr>
-          <a:lstStyle/>
-          <a:p>
-            <a:pPr algn="ctr">
-              <a:defRPr sz="1200" b="0">
-                <a:solidFill>
-                  <a:srgbClr val="CCCCCC"/>
-                </a:solidFill>
-                <a:latin typeface="Calibri"/>
-              </a:defRPr>
-            </a:pPr>
-            <a:r>
-              <a:t>Top-1 Accuracy</a:t>
-            </a:r>
-          </a:p>
-        </p:txBody>
-      </p:sp>
-      <p:sp>
-        <p:nvSpPr>
-          <p:cNvPr id="17" name="TextBox 16"/>
-          <p:cNvSpPr txBox="1"/>
-          <p:nvPr/>
-        </p:nvSpPr>
-        <p:spPr>
-          <a:xfrm>
-            <a:off x="640080" y="5029200"/>
-            <a:ext cx="10515600" cy="1371600"/>
-          </a:xfrm>
-          <a:prstGeom prst="rect">
-            <a:avLst/>
-          </a:prstGeom>
-          <a:noFill/>
-        </p:spPr>
-        <p:txBody>
-          <a:bodyPr wrap="square">
-            <a:spAutoFit/>
-          </a:bodyPr>
-          <a:lstStyle/>
-          <a:p>
-            <a:pPr>
-              <a:lnSpc>
-                <a:spcPct val="150000"/>
-              </a:lnSpc>
-              <a:spcAft>
-                <a:spcPts val="400"/>
-              </a:spcAft>
-            </a:pPr>
-            <a:r>
-              <a:rPr sz="1500" b="1">
-                <a:solidFill>
-                  <a:srgbClr val="2ECC71"/>
-                </a:solidFill>
-                <a:latin typeface="Calibri"/>
-              </a:rPr>
-              <a:t>  ▸  </a:t>
-            </a:r>
-            <a:r>
-              <a:rPr sz="1500" b="0">
-                <a:solidFill>
-                  <a:srgbClr val="FFFFFF"/>
-                </a:solidFill>
-                <a:latin typeface="Calibri"/>
-              </a:rPr>
-              <a:t>Primary drivers: ABE8e broader window (3-9) and enFnCas9 NRG PAM</a:t>
-            </a:r>
-          </a:p>
-          <a:p>
-            <a:pPr>
-              <a:lnSpc>
-                <a:spcPct val="150000"/>
-              </a:lnSpc>
-              <a:spcAft>
-                <a:spcPts val="400"/>
-              </a:spcAft>
-            </a:pPr>
-            <a:r>
-              <a:rPr sz="1500" b="1">
-                <a:solidFill>
-                  <a:srgbClr val="2ECC71"/>
-                </a:solidFill>
-                <a:latin typeface="Calibri"/>
-              </a:rPr>
-              <a:t>  ▸  </a:t>
-            </a:r>
-            <a:r>
-              <a:rPr sz="1500" b="0">
-                <a:solidFill>
-                  <a:srgbClr val="FFFFFF"/>
-                </a:solidFill>
-                <a:latin typeface="Calibri"/>
-              </a:rPr>
-              <a:t>PE still dominates (23/30) — this is correct, not a bias</a:t>
-            </a:r>
-          </a:p>
-          <a:p>
-            <a:pPr>
-              <a:lnSpc>
-                <a:spcPct val="150000"/>
-              </a:lnSpc>
-              <a:spcAft>
-                <a:spcPts val="400"/>
-              </a:spcAft>
-            </a:pPr>
-            <a:r>
-              <a:rPr sz="1500" b="1">
-                <a:solidFill>
-                  <a:srgbClr val="2ECC71"/>
-                </a:solidFill>
-                <a:latin typeface="Calibri"/>
-              </a:rPr>
-              <a:t>  ▸  </a:t>
-            </a:r>
-            <a:r>
-              <a:rPr sz="1500" b="1">
-                <a:solidFill>
-                  <a:srgbClr val="D95F02"/>
-                </a:solidFill>
-                <a:latin typeface="Calibri"/>
-              </a:rPr>
-              <a:t>Critical bug fixed: bystander severity was triple-counted in v2 scoring</a:t>
-            </a:r>
-          </a:p>
-        </p:txBody>
-      </p:sp>
-      <p:sp>
-        <p:nvSpPr>
-          <p:cNvPr id="18" name="TextBox 17"/>
           <p:cNvSpPr txBox="1"/>
           <p:nvPr/>
         </p:nvSpPr>
@@ -6922,9 +6772,33 @@
           </a:p>
         </p:txBody>
       </p:sp>
-      <p:sp>
-        <p:nvSpPr>
-          <p:cNvPr id="13" name="TextBox 12"/>
+      <p:pic>
+        <p:nvPicPr>
+          <p:cNvPr id="13" name="Picture 12" descr="Fig_BystanterFix.png"/>
+          <p:cNvPicPr>
+            <a:picLocks noChangeAspect="1"/>
+          </p:cNvPicPr>
+          <p:nvPr/>
+        </p:nvPicPr>
+        <p:blipFill>
+          <a:blip r:embed="rId2"/>
+          <a:stretch>
+            <a:fillRect/>
+          </a:stretch>
+        </p:blipFill>
+        <p:spPr>
+          <a:xfrm>
+            <a:off x="5943600" y="4114800"/>
+            <a:ext cx="5669280" cy="2468880"/>
+          </a:xfrm>
+          <a:prstGeom prst="rect">
+            <a:avLst/>
+          </a:prstGeom>
+        </p:spPr>
+      </p:pic>
+      <p:sp>
+        <p:nvSpPr>
+          <p:cNvPr id="14" name="TextBox 13"/>
           <p:cNvSpPr txBox="1"/>
           <p:nvPr/>
         </p:nvSpPr>
@@ -8751,9 +8625,33 @@
           </a:p>
         </p:txBody>
       </p:sp>
-      <p:sp>
-        <p:nvSpPr>
-          <p:cNvPr id="20" name="TextBox 19"/>
+      <p:pic>
+        <p:nvPicPr>
+          <p:cNvPr id="20" name="Picture 19" descr="Fig_CrossMethod_Agreement.png"/>
+          <p:cNvPicPr>
+            <a:picLocks noChangeAspect="1"/>
+          </p:cNvPicPr>
+          <p:nvPr/>
+        </p:nvPicPr>
+        <p:blipFill>
+          <a:blip r:embed="rId2"/>
+          <a:stretch>
+            <a:fillRect/>
+          </a:stretch>
+        </p:blipFill>
+        <p:spPr>
+          <a:xfrm>
+            <a:off x="1828800" y="3931920"/>
+            <a:ext cx="8503920" cy="2560320"/>
+          </a:xfrm>
+          <a:prstGeom prst="rect">
+            <a:avLst/>
+          </a:prstGeom>
+        </p:spPr>
+      </p:pic>
+      <p:sp>
+        <p:nvSpPr>
+          <p:cNvPr id="21" name="TextBox 20"/>
           <p:cNvSpPr txBox="1"/>
           <p:nvPr/>
         </p:nvSpPr>
@@ -9469,9 +9367,33 @@
           </a:p>
         </p:txBody>
       </p:sp>
-      <p:sp>
-        <p:nvSpPr>
-          <p:cNvPr id="9" name="TextBox 8"/>
+      <p:pic>
+        <p:nvPicPr>
+          <p:cNvPr id="9" name="Picture 8" descr="Fig_ConversionSim_CIs.png"/>
+          <p:cNvPicPr>
+            <a:picLocks noChangeAspect="1"/>
+          </p:cNvPicPr>
+          <p:nvPr/>
+        </p:nvPicPr>
+        <p:blipFill>
+          <a:blip r:embed="rId2"/>
+          <a:stretch>
+            <a:fillRect/>
+          </a:stretch>
+        </p:blipFill>
+        <p:spPr>
+          <a:xfrm>
+            <a:off x="457200" y="3474720"/>
+            <a:ext cx="11247120" cy="3200400"/>
+          </a:xfrm>
+          <a:prstGeom prst="rect">
+            <a:avLst/>
+          </a:prstGeom>
+        </p:spPr>
+      </p:pic>
+      <p:sp>
+        <p:nvSpPr>
+          <p:cNvPr id="10" name="TextBox 9"/>
           <p:cNvSpPr txBox="1"/>
           <p:nvPr/>
         </p:nvSpPr>
@@ -13619,9 +13541,33 @@
           </a:p>
         </p:txBody>
       </p:sp>
-      <p:sp>
-        <p:nvSpPr>
-          <p:cNvPr id="39" name="TextBox 38"/>
+      <p:pic>
+        <p:nvPicPr>
+          <p:cNvPr id="39" name="Picture 38" descr="Fig_ParameterProvenance.png"/>
+          <p:cNvPicPr>
+            <a:picLocks noChangeAspect="1"/>
+          </p:cNvPicPr>
+          <p:nvPr/>
+        </p:nvPicPr>
+        <p:blipFill>
+          <a:blip r:embed="rId2"/>
+          <a:stretch>
+            <a:fillRect/>
+          </a:stretch>
+        </p:blipFill>
+        <p:spPr>
+          <a:xfrm>
+            <a:off x="7772400" y="1371600"/>
+            <a:ext cx="3931920" cy="3931920"/>
+          </a:xfrm>
+          <a:prstGeom prst="rect">
+            <a:avLst/>
+          </a:prstGeom>
+        </p:spPr>
+      </p:pic>
+      <p:sp>
+        <p:nvSpPr>
+          <p:cNvPr id="40" name="TextBox 39"/>
           <p:cNvSpPr txBox="1"/>
           <p:nvPr/>
         </p:nvSpPr>
@@ -14288,9 +14234,33 @@
           </a:p>
         </p:txBody>
       </p:sp>
-      <p:sp>
-        <p:nvSpPr>
-          <p:cNvPr id="11" name="TextBox 10"/>
+      <p:pic>
+        <p:nvPicPr>
+          <p:cNvPr id="11" name="Picture 10" descr="Fig_LiteratureBenchmark.png"/>
+          <p:cNvPicPr>
+            <a:picLocks noChangeAspect="1"/>
+          </p:cNvPicPr>
+          <p:nvPr/>
+        </p:nvPicPr>
+        <p:blipFill>
+          <a:blip r:embed="rId2"/>
+          <a:stretch>
+            <a:fillRect/>
+          </a:stretch>
+        </p:blipFill>
+        <p:spPr>
+          <a:xfrm>
+            <a:off x="457200" y="4572000"/>
+            <a:ext cx="11247120" cy="2103120"/>
+          </a:xfrm>
+          <a:prstGeom prst="rect">
+            <a:avLst/>
+          </a:prstGeom>
+        </p:spPr>
+      </p:pic>
+      <p:sp>
+        <p:nvSpPr>
+          <p:cNvPr id="12" name="TextBox 11"/>
           <p:cNvSpPr txBox="1"/>
           <p:nvPr/>
         </p:nvSpPr>

</xml_diff>

<commit_message>
Reframe presentation for first-time audience, add SCD demo
- Remove all v1/v2/v3 version-based narrative from PPTX and speaker guide
- Reframe as unified tool presentation (audience has never seen this project)
- Figures updated: 'SpCas9-only vs Multi-nuclease' instead of 'v2 vs v3'
- Bystander figure: 'Why Scoring Architecture Matters' instead of 'Bug Fix'
- Delete outdated v2 speaker guide (LAB_MEETING_SPEAKER_GUIDE.md)
- Add Tier B footnote for ABE8e/BE4max-enFnCas9 extrapolated combinations
- Promote HBB sickle cell demo to primary demo in live demo script
- Clean version language from APP_DEMO_WALKTHROUGH and LIVE_DEMO_SCRIPT
- Update test count to 224 in codebase summary slide
</commit_message>
<xml_diff>
--- a/paper/CRISPRArchitect_v3_LabMeeting.pptx
+++ b/paper/CRISPRArchitect_v3_LabMeeting.pptx
@@ -3197,7 +3197,7 @@
               </a:defRPr>
             </a:pPr>
             <a:r>
-              <a:t>CRISPRArchitect v3</a:t>
+              <a:t>CRISPRArchitect</a:t>
             </a:r>
           </a:p>
         </p:txBody>
@@ -3437,8 +3437,8 @@
         </p:nvSpPr>
         <p:spPr>
           <a:xfrm>
-            <a:off x="8229600" y="5303520"/>
-            <a:ext cx="1188720" cy="457200"/>
+            <a:off x="7772400" y="5303520"/>
+            <a:ext cx="1280160" cy="457200"/>
           </a:xfrm>
           <a:prstGeom prst="roundRect">
             <a:avLst/>
@@ -3480,8 +3480,8 @@
         </p:nvSpPr>
         <p:spPr>
           <a:xfrm>
-            <a:off x="8229600" y="5349240"/>
-            <a:ext cx="1188720" cy="365760"/>
+            <a:off x="7772400" y="5349240"/>
+            <a:ext cx="1280160" cy="365760"/>
           </a:xfrm>
           <a:prstGeom prst="rect">
             <a:avLst/>
@@ -3495,15 +3495,15 @@
           <a:lstStyle/>
           <a:p>
             <a:pPr algn="ctr">
-              <a:defRPr sz="1600" b="1">
-                <a:solidFill>
-                  <a:srgbClr val="8899AA"/>
-                </a:solidFill>
-                <a:latin typeface="Calibri"/>
-              </a:defRPr>
-            </a:pPr>
-            <a:r>
-              <a:t>v1</a:t>
+              <a:defRPr sz="1400" b="1">
+                <a:solidFill>
+                  <a:srgbClr val="1B9E77"/>
+                </a:solidFill>
+                <a:latin typeface="Calibri"/>
+              </a:defRPr>
+            </a:pPr>
+            <a:r>
+              <a:t>5 Nucleases</a:t>
             </a:r>
           </a:p>
         </p:txBody>
@@ -3516,8 +3516,8 @@
         </p:nvSpPr>
         <p:spPr>
           <a:xfrm>
-            <a:off x="9692640" y="5303520"/>
-            <a:ext cx="1188720" cy="457200"/>
+            <a:off x="9326880" y="5303520"/>
+            <a:ext cx="1280160" cy="457200"/>
           </a:xfrm>
           <a:prstGeom prst="roundRect">
             <a:avLst/>
@@ -3559,8 +3559,8 @@
         </p:nvSpPr>
         <p:spPr>
           <a:xfrm>
-            <a:off x="9692640" y="5349240"/>
-            <a:ext cx="1188720" cy="365760"/>
+            <a:off x="9326880" y="5349240"/>
+            <a:ext cx="1280160" cy="365760"/>
           </a:xfrm>
           <a:prstGeom prst="rect">
             <a:avLst/>
@@ -3574,15 +3574,15 @@
           <a:lstStyle/>
           <a:p>
             <a:pPr algn="ctr">
-              <a:defRPr sz="1600" b="1">
-                <a:solidFill>
-                  <a:srgbClr val="1B9E77"/>
-                </a:solidFill>
-                <a:latin typeface="Calibri"/>
-              </a:defRPr>
-            </a:pPr>
-            <a:r>
-              <a:t>v2</a:t>
+              <a:defRPr sz="1400" b="1">
+                <a:solidFill>
+                  <a:srgbClr val="D95F02"/>
+                </a:solidFill>
+                <a:latin typeface="Calibri"/>
+              </a:defRPr>
+            </a:pPr>
+            <a:r>
+              <a:t>TOPSIS 6D</a:t>
             </a:r>
           </a:p>
         </p:txBody>
@@ -3595,8 +3595,8 @@
         </p:nvSpPr>
         <p:spPr>
           <a:xfrm>
-            <a:off x="11155680" y="5303520"/>
-            <a:ext cx="1188720" cy="457200"/>
+            <a:off x="10881360" y="5303520"/>
+            <a:ext cx="1280160" cy="457200"/>
           </a:xfrm>
           <a:prstGeom prst="roundRect">
             <a:avLst/>
@@ -3638,8 +3638,8 @@
         </p:nvSpPr>
         <p:spPr>
           <a:xfrm>
-            <a:off x="11155680" y="5349240"/>
-            <a:ext cx="1188720" cy="365760"/>
+            <a:off x="10881360" y="5349240"/>
+            <a:ext cx="1280160" cy="365760"/>
           </a:xfrm>
           <a:prstGeom prst="rect">
             <a:avLst/>
@@ -3653,15 +3653,15 @@
           <a:lstStyle/>
           <a:p>
             <a:pPr algn="ctr">
-              <a:defRPr sz="1600" b="1">
-                <a:solidFill>
-                  <a:srgbClr val="D95F02"/>
-                </a:solidFill>
-                <a:latin typeface="Calibri"/>
-              </a:defRPr>
-            </a:pPr>
-            <a:r>
-              <a:t>v3</a:t>
+              <a:defRPr sz="1400" b="1">
+                <a:solidFill>
+                  <a:srgbClr val="FFC107"/>
+                </a:solidFill>
+                <a:latin typeface="Calibri"/>
+              </a:defRPr>
+            </a:pPr>
+            <a:r>
+              <a:t>224 Tests</a:t>
             </a:r>
           </a:p>
         </p:txBody>
@@ -4589,7 +4589,7 @@
               </a:defRPr>
             </a:pPr>
             <a:r>
-              <a:t>v2 (SpCas9 + ABE7.10 only)</a:t>
+              <a:t>SpCas9 + ABE7.10 only</a:t>
             </a:r>
           </a:p>
         </p:txBody>
@@ -4787,7 +4787,7 @@
               </a:defRPr>
             </a:pPr>
             <a:r>
-              <a:t>v3 (5 nucleases + ABE8e)</a:t>
+              <a:t>Multi-Nuclease (5 nucleases + ABE8e)</a:t>
             </a:r>
           </a:p>
         </p:txBody>
@@ -5063,7 +5063,7 @@
               </a:defRPr>
             </a:pPr>
             <a:r>
-              <a:t>v3 KEY FINDING</a:t>
+              <a:t>KEY FINDING</a:t>
             </a:r>
           </a:p>
         </p:txBody>
@@ -5099,7 +5099,7 @@
               </a:defRPr>
             </a:pPr>
             <a:r>
-              <a:t>Base Editing Rescued: 0/30 to 6/30</a:t>
+              <a:t>Multi-Nuclease Engine Rescues Base Editing</a:t>
             </a:r>
           </a:p>
         </p:txBody>
@@ -5221,11 +5221,11 @@
               </a:defRPr>
             </a:pPr>
             <a:r>
-              <a:t>v3 strategy distribution: BE 20% | PE 77% | HDR 3%</a:t>
+              <a:t>With multi-nuclease: BE 20% | PE 77% | HDR 3%</a:t>
             </a:r>
             <a:br/>
             <a:r>
-              <a:t>(v2 was: BE 0% | PE 97% | HDR 3%)</a:t>
+              <a:t>(SpCas9 only: BE 0% | PE 97% | HDR 3%)</a:t>
             </a:r>
           </a:p>
         </p:txBody>
@@ -5364,7 +5364,7 @@
               </a:defRPr>
             </a:pPr>
             <a:r>
-              <a:t>BE v3</a:t>
+              <a:t>BE (multi-nuc.)</a:t>
             </a:r>
           </a:p>
         </p:txBody>
@@ -5479,7 +5479,7 @@
               </a:defRPr>
             </a:pPr>
             <a:r>
-              <a:t>BE v2</a:t>
+              <a:t>BE (SpCas9)</a:t>
             </a:r>
           </a:p>
         </p:txBody>
@@ -5523,11 +5523,11 @@
             </a:r>
             <a:br/>
             <a:r>
-              <a:t>  enFnCas9 NRG PAM</a:t>
+              <a:t>  enFnCas9 NRG PAM (~2x target sites)</a:t>
             </a:r>
             <a:br/>
             <a:r>
-              <a:t>Bug fixed: bystander triple-count</a:t>
+              <a:t>  Bystander scoring corrected</a:t>
             </a:r>
           </a:p>
         </p:txBody>
@@ -6787,7 +6787,7 @@
               </a:defRPr>
             </a:pPr>
             <a:r>
-              <a:t>CRITICAL BUG FIX</a:t>
+              <a:t>SCORING ARCHITECTURE</a:t>
             </a:r>
           </a:p>
         </p:txBody>
@@ -6823,7 +6823,7 @@
               </a:defRPr>
             </a:pPr>
             <a:r>
-              <a:t>Bystander Triple-Counting Eliminated</a:t>
+              <a:t>Why Bystander Scoring Matters</a:t>
             </a:r>
           </a:p>
         </p:txBody>
@@ -6902,7 +6902,7 @@
               </a:defRPr>
             </a:pPr>
             <a:r>
-              <a:t>Root cause of the degenerate 'always PE' pattern in v2</a:t>
+              <a:t>Redundant penalty channels can create degenerate 'always PE' patterns</a:t>
             </a:r>
           </a:p>
         </p:txBody>
@@ -6981,7 +6981,7 @@
               </a:defRPr>
             </a:pPr>
             <a:r>
-              <a:t>v2 Bug: 3 Penalty Channels</a:t>
+              <a:t>Problem: Triple-Counted Penalty</a:t>
             </a:r>
           </a:p>
         </p:txBody>
@@ -7243,7 +7243,7 @@
               </a:defRPr>
             </a:pPr>
             <a:r>
-              <a:t>v3 Fix: Single Consequence Dimension</a:t>
+              <a:t>Solution: Single Consequence Dimension</a:t>
             </a:r>
           </a:p>
         </p:txBody>
@@ -14333,7 +14333,7 @@
               </a:defRPr>
             </a:pPr>
             <a:r>
-              <a:t>Benchmark Results: v2 vs v3</a:t>
+              <a:t>Benchmark Results</a:t>
             </a:r>
           </a:p>
         </p:txBody>
@@ -14412,7 +14412,7 @@
               </a:defRPr>
             </a:pPr>
             <a:r>
-              <a:t>30 ClinVar cases, verified GRCh38 coordinates</a:t>
+              <a:t>30 ClinVar cases | verified GRCh38 coordinates | all references PMID-confirmed</a:t>
             </a:r>
           </a:p>
         </p:txBody>
@@ -14491,7 +14491,7 @@
               </a:defRPr>
             </a:pPr>
             <a:r>
-              <a:t>v2 Results (SpCas9 + ABE7.10)</a:t>
+              <a:t>ClinVar Benchmark (30 cases)</a:t>
             </a:r>
           </a:p>
         </p:txBody>
@@ -14562,7 +14562,7 @@
                 </a:solidFill>
                 <a:latin typeface="Calibri"/>
               </a:rPr>
-              <a:t>Rejection accuracy: 90.0% (27/30)</a:t>
+              <a:t>Rejection accuracy: 86.7% (26/30)</a:t>
             </a:r>
           </a:p>
           <a:p>
@@ -14590,11 +14590,11 @@
             <a:r>
               <a:rPr sz="1400" b="0">
                 <a:solidFill>
-                  <a:srgbClr val="FFFFFF"/>
-                </a:solidFill>
-                <a:latin typeface="Calibri"/>
-              </a:rPr>
-              <a:t>Strategy: PE=29, HDR=1, BE=0</a:t>
+                  <a:srgbClr val="8899AA"/>
+                </a:solidFill>
+                <a:latin typeface="Calibri"/>
+              </a:rPr>
+              <a:t>Strategy distribution:</a:t>
             </a:r>
           </a:p>
           <a:p>
@@ -14604,13 +14604,13 @@
               </a:lnSpc>
             </a:pPr>
             <a:r>
-              <a:rPr sz="1400" b="0">
-                <a:solidFill>
-                  <a:srgbClr val="FFFFFF"/>
-                </a:solidFill>
-                <a:latin typeface="Calibri"/>
-              </a:rPr>
-              <a:t/>
+              <a:rPr sz="1400" b="1">
+                <a:solidFill>
+                  <a:srgbClr val="D95F02"/>
+                </a:solidFill>
+                <a:latin typeface="Calibri"/>
+              </a:rPr>
+              <a:t>  PE: 23/30 (77%)</a:t>
             </a:r>
           </a:p>
           <a:p>
@@ -14620,13 +14620,13 @@
               </a:lnSpc>
             </a:pPr>
             <a:r>
-              <a:rPr sz="1400" b="0">
-                <a:solidFill>
-                  <a:srgbClr val="8899AA"/>
-                </a:solidFill>
-                <a:latin typeface="Calibri"/>
-              </a:rPr>
-              <a:t>Scoring: 5D weighted sum</a:t>
+              <a:rPr sz="1400" b="1">
+                <a:solidFill>
+                  <a:srgbClr val="2ECC71"/>
+                </a:solidFill>
+                <a:latin typeface="Calibri"/>
+              </a:rPr>
+              <a:t>  BE:  6/30 (20%)</a:t>
             </a:r>
           </a:p>
           <a:p>
@@ -14638,11 +14638,43 @@
             <a:r>
               <a:rPr sz="1400" b="0">
                 <a:solidFill>
-                  <a:srgbClr val="8899AA"/>
-                </a:solidFill>
-                <a:latin typeface="Calibri"/>
-              </a:rPr>
-              <a:t>Tests: 123 passing</a:t>
+                  <a:srgbClr val="FFC107"/>
+                </a:solidFill>
+                <a:latin typeface="Calibri"/>
+              </a:rPr>
+              <a:t>  HDR: 1/30  (3%)</a:t>
+            </a:r>
+          </a:p>
+          <a:p>
+            <a:pPr>
+              <a:lnSpc>
+                <a:spcPct val="130000"/>
+              </a:lnSpc>
+            </a:pPr>
+            <a:r>
+              <a:rPr sz="1400" b="0">
+                <a:solidFill>
+                  <a:srgbClr val="FFFFFF"/>
+                </a:solidFill>
+                <a:latin typeface="Calibri"/>
+              </a:rPr>
+              <a:t/>
+            </a:r>
+          </a:p>
+          <a:p>
+            <a:pPr>
+              <a:lnSpc>
+                <a:spcPct val="130000"/>
+              </a:lnSpc>
+            </a:pPr>
+            <a:r>
+              <a:rPr sz="1400" b="0">
+                <a:solidFill>
+                  <a:srgbClr val="1B9E77"/>
+                </a:solidFill>
+                <a:latin typeface="Calibri"/>
+              </a:rPr>
+              <a:t>Scoring: 6D TOPSIS + Pareto + VIKOR/WPM</a:t>
             </a:r>
           </a:p>
         </p:txBody>
@@ -14721,7 +14753,7 @@
               </a:defRPr>
             </a:pPr>
             <a:r>
-              <a:t>v3 Results (multi-nuclease + TOPSIS 6D)</a:t>
+              <a:t>Literature Benchmark + Technical</a:t>
             </a:r>
           </a:p>
         </p:txBody>
@@ -14760,7 +14792,7 @@
                 </a:solidFill>
                 <a:latin typeface="Calibri"/>
               </a:rPr>
-              <a:t>Top-1 accuracy: 86.7% (26/30)</a:t>
+              <a:t>33 published cases (20 genes)</a:t>
             </a:r>
           </a:p>
           <a:p>
@@ -14776,7 +14808,7 @@
                 </a:solidFill>
                 <a:latin typeface="Calibri"/>
               </a:rPr>
-              <a:t>Top-3 accuracy: 96.7% (29/30)</a:t>
+              <a:t>Top-1 concordance: 30%</a:t>
             </a:r>
           </a:p>
           <a:p>
@@ -14792,7 +14824,7 @@
                 </a:solidFill>
                 <a:latin typeface="Calibri"/>
               </a:rPr>
-              <a:t>Rejection accuracy: 86.7% (26/30)</a:t>
+              <a:t>Top-3 concordance: 80%</a:t>
             </a:r>
           </a:p>
           <a:p>
@@ -14804,11 +14836,11 @@
             <a:r>
               <a:rPr sz="1400" b="0">
                 <a:solidFill>
-                  <a:srgbClr val="FFFFFF"/>
-                </a:solidFill>
-                <a:latin typeface="Calibri"/>
-              </a:rPr>
-              <a:t/>
+                  <a:srgbClr val="8899AA"/>
+                </a:solidFill>
+                <a:latin typeface="Calibri"/>
+              </a:rPr>
+              <a:t>(Discordance: pre-PE HDR papers)</a:t>
             </a:r>
           </a:p>
           <a:p>
@@ -14818,13 +14850,13 @@
               </a:lnSpc>
             </a:pPr>
             <a:r>
-              <a:rPr sz="1400" b="1">
-                <a:solidFill>
-                  <a:srgbClr val="2ECC71"/>
-                </a:solidFill>
-                <a:latin typeface="Calibri"/>
-              </a:rPr>
-              <a:t>Strategy: PE=23, BE=6, HDR=1</a:t>
+              <a:rPr sz="1400" b="0">
+                <a:solidFill>
+                  <a:srgbClr val="FFFFFF"/>
+                </a:solidFill>
+                <a:latin typeface="Calibri"/>
+              </a:rPr>
+              <a:t/>
             </a:r>
           </a:p>
           <a:p>
@@ -14834,13 +14866,13 @@
               </a:lnSpc>
             </a:pPr>
             <a:r>
-              <a:rPr sz="1400" b="0">
-                <a:solidFill>
-                  <a:srgbClr val="FFFFFF"/>
-                </a:solidFill>
-                <a:latin typeface="Calibri"/>
-              </a:rPr>
-              <a:t/>
+              <a:rPr sz="1400" b="1">
+                <a:solidFill>
+                  <a:srgbClr val="2ECC71"/>
+                </a:solidFill>
+                <a:latin typeface="Calibri"/>
+              </a:rPr>
+              <a:t>Cross-method: 100% concordance</a:t>
             </a:r>
           </a:p>
           <a:p>
@@ -14852,11 +14884,11 @@
             <a:r>
               <a:rPr sz="1400" b="0">
                 <a:solidFill>
-                  <a:srgbClr val="D95F02"/>
-                </a:solidFill>
-                <a:latin typeface="Calibri"/>
-              </a:rPr>
-              <a:t>Scoring: 6D TOPSIS + Pareto + VIKOR/WPM</a:t>
+                  <a:srgbClr val="1B9E77"/>
+                </a:solidFill>
+                <a:latin typeface="Calibri"/>
+              </a:rPr>
+              <a:t>  (TOPSIS = VIKOR = WPM)</a:t>
             </a:r>
           </a:p>
           <a:p>
@@ -14868,11 +14900,11 @@
             <a:r>
               <a:rPr sz="1400" b="0">
                 <a:solidFill>
-                  <a:srgbClr val="D95F02"/>
-                </a:solidFill>
-                <a:latin typeface="Calibri"/>
-              </a:rPr>
-              <a:t>Tests: 198 passing</a:t>
+                  <a:srgbClr val="1B9E77"/>
+                </a:solidFill>
+                <a:latin typeface="Calibri"/>
+              </a:rPr>
+              <a:t>224 tests passing, 0 failures</a:t>
             </a:r>
           </a:p>
           <a:p>
@@ -14884,11 +14916,11 @@
             <a:r>
               <a:rPr sz="1400" b="0">
                 <a:solidFill>
-                  <a:srgbClr val="D95F02"/>
-                </a:solidFill>
-                <a:latin typeface="Calibri"/>
-              </a:rPr>
-              <a:t>SEs/CIs on all outputs</a:t>
+                  <a:srgbClr val="1B9E77"/>
+                </a:solidFill>
+                <a:latin typeface="Calibri"/>
+              </a:rPr>
+              <a:t>All 20 manuscript refs verified</a:t>
             </a:r>
           </a:p>
           <a:p>
@@ -14900,11 +14932,11 @@
             <a:r>
               <a:rPr sz="1400" b="0">
                 <a:solidFill>
-                  <a:srgbClr val="D95F02"/>
-                </a:solidFill>
-                <a:latin typeface="Calibri"/>
-              </a:rPr>
-              <a:t>All 20 references web-verified</a:t>
+                  <a:srgbClr val="1B9E77"/>
+                </a:solidFill>
+                <a:latin typeface="Calibri"/>
+              </a:rPr>
+              <a:t>Every parameter evidence-tagged</a:t>
             </a:r>
           </a:p>
         </p:txBody>
@@ -15026,7 +15058,7 @@
               </a:defRPr>
             </a:pPr>
             <a:r>
-              <a:t>v3 Codebase Summary</a:t>
+              <a:t>Codebase Summary</a:t>
             </a:r>
           </a:p>
         </p:txBody>
@@ -15105,7 +15137,7 @@
               </a:defRPr>
             </a:pPr>
             <a:r>
-              <a:t>Version 3.0.0 | MIT License | github.com/visvikbharti/CRISPRArchitect</a:t>
+              <a:t>MIT License | github.com/visvikbharti/CRISPRArchitect</a:t>
             </a:r>
           </a:p>
         </p:txBody>
@@ -15184,7 +15216,7 @@
               </a:defRPr>
             </a:pPr>
             <a:r>
-              <a:t>198</a:t>
+              <a:t>224</a:t>
             </a:r>
           </a:p>
         </p:txBody>
@@ -15299,7 +15331,7 @@
               </a:defRPr>
             </a:pPr>
             <a:r>
-              <a:t>3.0.0</a:t>
+              <a:t>~36,500</a:t>
             </a:r>
           </a:p>
         </p:txBody>
@@ -15335,7 +15367,7 @@
               </a:defRPr>
             </a:pPr>
             <a:r>
-              <a:t>Version</a:t>
+              <a:t>Lines of Python</a:t>
             </a:r>
           </a:p>
         </p:txBody>
@@ -15414,7 +15446,7 @@
               </a:defRPr>
             </a:pPr>
             <a:r>
-              <a:t>~36,500</a:t>
+              <a:t>5 × 9</a:t>
             </a:r>
           </a:p>
         </p:txBody>
@@ -15450,7 +15482,7 @@
               </a:defRPr>
             </a:pPr>
             <a:r>
-              <a:t>Lines of Code</a:t>
+              <a:t>Nucleases × Editors</a:t>
             </a:r>
           </a:p>
         </p:txBody>
@@ -18829,7 +18861,7 @@
               </a:defRPr>
             </a:pPr>
             <a:r>
-              <a:t>github.com/visvikbharti/CRISPRArchitect  |  MIT License  |  v3.0.0</a:t>
+              <a:t>github.com/visvikbharti/CRISPRArchitect  |  MIT License</a:t>
             </a:r>
           </a:p>
         </p:txBody>
@@ -18865,7 +18897,7 @@
               </a:defRPr>
             </a:pPr>
             <a:r>
-              <a:t>Key takeaway: CRISPRArchitect v3 provides transparent,</a:t>
+              <a:t>Key takeaway: CRISPRArchitect provides transparent,</a:t>
             </a:r>
             <a:br/>
             <a:r>
@@ -19596,7 +19628,7 @@
               </a:defRPr>
             </a:pPr>
             <a:r>
-              <a:t>v1 Foundation: 6 Simulation Modules</a:t>
+              <a:t>Biophysical Simulation Modules</a:t>
             </a:r>
           </a:p>
         </p:txBody>
@@ -20679,7 +20711,7 @@
               </a:defRPr>
             </a:pPr>
             <a:r>
-              <a:t>v2: Transcript-Aware Pipeline</a:t>
+              <a:t>Initial Analysis: SpCas9-Only Benchmark</a:t>
             </a:r>
           </a:p>
         </p:txBody>
@@ -20758,7 +20790,7 @@
               </a:defRPr>
             </a:pPr>
             <a:r>
-              <a:t>~9,400 LOC | 30 ClinVar benchmark cases | 123 tests</a:t>
+              <a:t>30 ClinVar cases | Transcript-aware pipeline | GRCh38 coordinates</a:t>
             </a:r>
           </a:p>
         </p:txBody>
@@ -20921,7 +20953,7 @@
                 </a:solidFill>
                 <a:latin typeface="Calibri"/>
               </a:rPr>
-              <a:t>Weighted-sum scoring with consequence adjustments</a:t>
+              <a:t>Scored with weighted-sum across 5 dimensions</a:t>
             </a:r>
           </a:p>
           <a:p>
@@ -21028,7 +21060,7 @@
               </a:defRPr>
             </a:pPr>
             <a:r>
-              <a:t>v2 Benchmark Results</a:t>
+              <a:t>SpCas9-Only Results</a:t>
             </a:r>
           </a:p>
         </p:txBody>
@@ -21352,7 +21384,7 @@
               </a:defRPr>
             </a:pPr>
             <a:r>
-              <a:t>v2 KEY FINDING</a:t>
+              <a:t>KEY FINDING</a:t>
             </a:r>
           </a:p>
         </p:txBody>
@@ -21467,7 +21499,7 @@
               </a:defRPr>
             </a:pPr>
             <a:r>
-              <a:t>The most important result from v2</a:t>
+              <a:t>The most important finding from our SpCas9-only analysis</a:t>
             </a:r>
           </a:p>
         </p:txBody>
@@ -21693,7 +21725,7 @@
                 </a:solidFill>
                 <a:latin typeface="Calibri"/>
               </a:rPr>
-              <a:t>This motivated v3: broader PAM nucleases + wider editing windows</a:t>
+              <a:t>This motivated expanding to multiple nucleases + wider editing windows</a:t>
             </a:r>
           </a:p>
         </p:txBody>
@@ -21834,7 +21866,7 @@
               </a:defRPr>
             </a:pPr>
             <a:r>
-              <a:t>VERSION 3.0</a:t>
+              <a:t>CORE INNOVATIONS</a:t>
             </a:r>
           </a:p>
         </p:txBody>
@@ -21870,7 +21902,7 @@
               </a:defRPr>
             </a:pPr>
             <a:r>
-              <a:t>What's New in v3?</a:t>
+              <a:t>Three Key Technical Contributions</a:t>
             </a:r>
           </a:p>
         </p:txBody>
@@ -21949,7 +21981,7 @@
               </a:defRPr>
             </a:pPr>
             <a:r>
-              <a:t>Three major capabilities + scientific rigor overhaul</a:t>
+              <a:t>Multi-nuclease evaluation + principled scoring + statistical rigor</a:t>
             </a:r>
           </a:p>
         </p:txBody>
@@ -22119,7 +22151,7 @@
             </a:r>
             <a:br/>
             <a:r>
-              <a:t>rescued BE: 0/30 → 6/30</a:t>
+              <a:t>BE rescued at 6/30 loci</a:t>
             </a:r>
           </a:p>
         </p:txBody>
@@ -24046,7 +24078,7 @@
               </a:defRPr>
             </a:pPr>
             <a:r>
-              <a:t>* enFnCas9 stagger is [ASSUMED] — not directly measured. HDR multiplier is [ASSUMED]. See parameter provenance.</a:t>
+              <a:t>* enFnCas9 stagger is [ASSUMED] — not directly measured. HDR multiplier is [ASSUMED]. ** ABE8e-enFnCas9 and BE4max-enFnCas9 are Tier B (extrapolated from components; no published fusion data).</a:t>
             </a:r>
           </a:p>
         </p:txBody>
@@ -24267,7 +24299,7 @@
                 </a:solidFill>
                 <a:latin typeface="Calibri"/>
               </a:rPr>
-              <a:t>ABE8e + enFnCas9: NRG PAM</a:t>
+              <a:t>ABE8e + enFnCas9: NRG PAM **</a:t>
             </a:r>
           </a:p>
           <a:p>
@@ -24354,7 +24386,7 @@
                 </a:solidFill>
                 <a:latin typeface="Calibri"/>
               </a:rPr>
-              <a:t>BE4max + enFnCas9: NRG PAM</a:t>
+              <a:t>BE4max + enFnCas9: NRG PAM **</a:t>
             </a:r>
           </a:p>
           <a:p>

</xml_diff>